<commit_message>
fix: use compatible Chinese font in pitch deck
</commit_message>
<xml_diff>
--- a/output/presentation/SkillForge_三分钟路演_v1.pptx
+++ b/output/presentation/SkillForge_三分钟路演_v1.pptx
@@ -1682,9 +1682,9 @@
                 <a:solidFill>
                   <a:srgbClr val="050505"/>
                 </a:solidFill>
-                <a:latin typeface="PingFang SC"/>
-                <a:ea typeface="PingFang SC"/>
-                <a:cs typeface="PingFang SC"/>
+                <a:latin typeface="Microsoft YaHei"/>
+                <a:ea typeface="Microsoft YaHei"/>
+                <a:cs typeface="Microsoft YaHei"/>
               </a:defRPr>
             </a:pPr>
           </a:p>
@@ -1733,9 +1733,9 @@
                 <a:solidFill>
                   <a:srgbClr val="5F6368"/>
                 </a:solidFill>
-                <a:latin typeface="PingFang SC"/>
-                <a:ea typeface="PingFang SC"/>
-                <a:cs typeface="PingFang SC"/>
+                <a:latin typeface="Microsoft YaHei"/>
+                <a:ea typeface="Microsoft YaHei"/>
+                <a:cs typeface="Microsoft YaHei"/>
               </a:defRPr>
             </a:pPr>
           </a:p>
@@ -1916,9 +1916,9 @@
                 <a:solidFill>
                   <a:srgbClr val="3D8DFF"/>
                 </a:solidFill>
-                <a:latin typeface="PingFang SC"/>
-                <a:ea typeface="PingFang SC"/>
-                <a:cs typeface="PingFang SC"/>
+                <a:latin typeface="Microsoft YaHei"/>
+                <a:ea typeface="Microsoft YaHei"/>
+                <a:cs typeface="Microsoft YaHei"/>
               </a:defRPr>
             </a:pPr>
             <a:r>
@@ -1961,9 +1961,9 @@
                 <a:solidFill>
                   <a:srgbClr val="050505"/>
                 </a:solidFill>
-                <a:latin typeface="PingFang SC"/>
-                <a:ea typeface="PingFang SC"/>
-                <a:cs typeface="PingFang SC"/>
+                <a:latin typeface="Microsoft YaHei"/>
+                <a:ea typeface="Microsoft YaHei"/>
+                <a:cs typeface="Microsoft YaHei"/>
               </a:defRPr>
             </a:pPr>
             <a:r>
@@ -2007,9 +2007,9 @@
                 <a:solidFill>
                   <a:srgbClr val="050505"/>
                 </a:solidFill>
-                <a:latin typeface="PingFang SC"/>
-                <a:ea typeface="PingFang SC"/>
-                <a:cs typeface="PingFang SC"/>
+                <a:latin typeface="Microsoft YaHei"/>
+                <a:ea typeface="Microsoft YaHei"/>
+                <a:cs typeface="Microsoft YaHei"/>
               </a:defRPr>
             </a:pPr>
             <a:r>
@@ -2088,9 +2088,9 @@
                 <a:solidFill>
                   <a:srgbClr val="13233A"/>
                 </a:solidFill>
-                <a:latin typeface="PingFang SC"/>
-                <a:ea typeface="PingFang SC"/>
-                <a:cs typeface="PingFang SC"/>
+                <a:latin typeface="Microsoft YaHei"/>
+                <a:ea typeface="Microsoft YaHei"/>
+                <a:cs typeface="Microsoft YaHei"/>
               </a:defRPr>
             </a:pPr>
             <a:r>
@@ -2133,9 +2133,9 @@
                 <a:solidFill>
                   <a:srgbClr val="5F6368"/>
                 </a:solidFill>
-                <a:latin typeface="PingFang SC"/>
-                <a:ea typeface="PingFang SC"/>
-                <a:cs typeface="PingFang SC"/>
+                <a:latin typeface="Microsoft YaHei"/>
+                <a:ea typeface="Microsoft YaHei"/>
+                <a:cs typeface="Microsoft YaHei"/>
               </a:defRPr>
             </a:pPr>
             <a:r>
@@ -2207,9 +2207,9 @@
                 <a:solidFill>
                   <a:srgbClr val="3D8DFF"/>
                 </a:solidFill>
-                <a:latin typeface="PingFang SC"/>
-                <a:ea typeface="PingFang SC"/>
-                <a:cs typeface="PingFang SC"/>
+                <a:latin typeface="Microsoft YaHei"/>
+                <a:ea typeface="Microsoft YaHei"/>
+                <a:cs typeface="Microsoft YaHei"/>
               </a:defRPr>
             </a:pPr>
             <a:r>
@@ -2252,9 +2252,9 @@
                 <a:solidFill>
                   <a:srgbClr val="050505"/>
                 </a:solidFill>
-                <a:latin typeface="PingFang SC"/>
-                <a:ea typeface="PingFang SC"/>
-                <a:cs typeface="PingFang SC"/>
+                <a:latin typeface="Microsoft YaHei"/>
+                <a:ea typeface="Microsoft YaHei"/>
+                <a:cs typeface="Microsoft YaHei"/>
               </a:defRPr>
             </a:pPr>
             <a:r>
@@ -2297,9 +2297,9 @@
                 <a:solidFill>
                   <a:srgbClr val="5F6368"/>
                 </a:solidFill>
-                <a:latin typeface="PingFang SC"/>
-                <a:ea typeface="PingFang SC"/>
-                <a:cs typeface="PingFang SC"/>
+                <a:latin typeface="Microsoft YaHei"/>
+                <a:ea typeface="Microsoft YaHei"/>
+                <a:cs typeface="Microsoft YaHei"/>
               </a:defRPr>
             </a:pPr>
             <a:r>
@@ -2377,9 +2377,9 @@
                 <a:solidFill>
                   <a:srgbClr val="050505"/>
                 </a:solidFill>
-                <a:latin typeface="PingFang SC"/>
-                <a:ea typeface="PingFang SC"/>
-                <a:cs typeface="PingFang SC"/>
+                <a:latin typeface="Microsoft YaHei"/>
+                <a:ea typeface="Microsoft YaHei"/>
+                <a:cs typeface="Microsoft YaHei"/>
               </a:defRPr>
             </a:pPr>
             <a:r>
@@ -2458,9 +2458,9 @@
                 <a:solidFill>
                   <a:srgbClr val="5F6368"/>
                 </a:solidFill>
-                <a:latin typeface="PingFang SC"/>
-                <a:ea typeface="PingFang SC"/>
-                <a:cs typeface="PingFang SC"/>
+                <a:latin typeface="Microsoft YaHei"/>
+                <a:ea typeface="Microsoft YaHei"/>
+                <a:cs typeface="Microsoft YaHei"/>
               </a:defRPr>
             </a:pPr>
             <a:r>
@@ -2503,9 +2503,9 @@
                 <a:solidFill>
                   <a:srgbClr val="050505"/>
                 </a:solidFill>
-                <a:latin typeface="PingFang SC"/>
-                <a:ea typeface="PingFang SC"/>
-                <a:cs typeface="PingFang SC"/>
+                <a:latin typeface="Microsoft YaHei"/>
+                <a:ea typeface="Microsoft YaHei"/>
+                <a:cs typeface="Microsoft YaHei"/>
               </a:defRPr>
             </a:pPr>
             <a:r>
@@ -2548,9 +2548,9 @@
                 <a:solidFill>
                   <a:srgbClr val="050505"/>
                 </a:solidFill>
-                <a:latin typeface="PingFang SC"/>
-                <a:ea typeface="PingFang SC"/>
-                <a:cs typeface="PingFang SC"/>
+                <a:latin typeface="Microsoft YaHei"/>
+                <a:ea typeface="Microsoft YaHei"/>
+                <a:cs typeface="Microsoft YaHei"/>
               </a:defRPr>
             </a:pPr>
             <a:r>
@@ -2593,9 +2593,9 @@
                 <a:solidFill>
                   <a:srgbClr val="050505"/>
                 </a:solidFill>
-                <a:latin typeface="PingFang SC"/>
-                <a:ea typeface="PingFang SC"/>
-                <a:cs typeface="PingFang SC"/>
+                <a:latin typeface="Microsoft YaHei"/>
+                <a:ea typeface="Microsoft YaHei"/>
+                <a:cs typeface="Microsoft YaHei"/>
               </a:defRPr>
             </a:pPr>
             <a:r>
@@ -2770,9 +2770,9 @@
                 <a:solidFill>
                   <a:srgbClr val="3D8DFF"/>
                 </a:solidFill>
-                <a:latin typeface="PingFang SC"/>
-                <a:ea typeface="PingFang SC"/>
-                <a:cs typeface="PingFang SC"/>
+                <a:latin typeface="Microsoft YaHei"/>
+                <a:ea typeface="Microsoft YaHei"/>
+                <a:cs typeface="Microsoft YaHei"/>
               </a:defRPr>
             </a:pPr>
             <a:r>
@@ -2815,9 +2815,9 @@
                 <a:solidFill>
                   <a:srgbClr val="050505"/>
                 </a:solidFill>
-                <a:latin typeface="PingFang SC"/>
-                <a:ea typeface="PingFang SC"/>
-                <a:cs typeface="PingFang SC"/>
+                <a:latin typeface="Microsoft YaHei"/>
+                <a:ea typeface="Microsoft YaHei"/>
+                <a:cs typeface="Microsoft YaHei"/>
               </a:defRPr>
             </a:pPr>
             <a:r>
@@ -2860,9 +2860,9 @@
                 <a:solidFill>
                   <a:srgbClr val="5F6368"/>
                 </a:solidFill>
-                <a:latin typeface="PingFang SC"/>
-                <a:ea typeface="PingFang SC"/>
-                <a:cs typeface="PingFang SC"/>
+                <a:latin typeface="Microsoft YaHei"/>
+                <a:ea typeface="Microsoft YaHei"/>
+                <a:cs typeface="Microsoft YaHei"/>
               </a:defRPr>
             </a:pPr>
             <a:r>
@@ -2905,9 +2905,9 @@
                 <a:solidFill>
                   <a:srgbClr val="3D8DFF"/>
                 </a:solidFill>
-                <a:latin typeface="PingFang SC"/>
-                <a:ea typeface="PingFang SC"/>
-                <a:cs typeface="PingFang SC"/>
+                <a:latin typeface="Microsoft YaHei"/>
+                <a:ea typeface="Microsoft YaHei"/>
+                <a:cs typeface="Microsoft YaHei"/>
               </a:defRPr>
             </a:pPr>
             <a:r>
@@ -2950,9 +2950,9 @@
                 <a:solidFill>
                   <a:srgbClr val="050505"/>
                 </a:solidFill>
-                <a:latin typeface="PingFang SC"/>
-                <a:ea typeface="PingFang SC"/>
-                <a:cs typeface="PingFang SC"/>
+                <a:latin typeface="Microsoft YaHei"/>
+                <a:ea typeface="Microsoft YaHei"/>
+                <a:cs typeface="Microsoft YaHei"/>
               </a:defRPr>
             </a:pPr>
             <a:r>
@@ -2995,9 +2995,9 @@
                 <a:solidFill>
                   <a:srgbClr val="5F6368"/>
                 </a:solidFill>
-                <a:latin typeface="PingFang SC"/>
-                <a:ea typeface="PingFang SC"/>
-                <a:cs typeface="PingFang SC"/>
+                <a:latin typeface="Microsoft YaHei"/>
+                <a:ea typeface="Microsoft YaHei"/>
+                <a:cs typeface="Microsoft YaHei"/>
               </a:defRPr>
             </a:pPr>
             <a:r>
@@ -3040,9 +3040,9 @@
                 <a:solidFill>
                   <a:srgbClr val="3D8DFF"/>
                 </a:solidFill>
-                <a:latin typeface="PingFang SC"/>
-                <a:ea typeface="PingFang SC"/>
-                <a:cs typeface="PingFang SC"/>
+                <a:latin typeface="Microsoft YaHei"/>
+                <a:ea typeface="Microsoft YaHei"/>
+                <a:cs typeface="Microsoft YaHei"/>
               </a:defRPr>
             </a:pPr>
             <a:r>
@@ -3085,9 +3085,9 @@
                 <a:solidFill>
                   <a:srgbClr val="050505"/>
                 </a:solidFill>
-                <a:latin typeface="PingFang SC"/>
-                <a:ea typeface="PingFang SC"/>
-                <a:cs typeface="PingFang SC"/>
+                <a:latin typeface="Microsoft YaHei"/>
+                <a:ea typeface="Microsoft YaHei"/>
+                <a:cs typeface="Microsoft YaHei"/>
               </a:defRPr>
             </a:pPr>
             <a:r>
@@ -3130,9 +3130,9 @@
                 <a:solidFill>
                   <a:srgbClr val="5F6368"/>
                 </a:solidFill>
-                <a:latin typeface="PingFang SC"/>
-                <a:ea typeface="PingFang SC"/>
-                <a:cs typeface="PingFang SC"/>
+                <a:latin typeface="Microsoft YaHei"/>
+                <a:ea typeface="Microsoft YaHei"/>
+                <a:cs typeface="Microsoft YaHei"/>
               </a:defRPr>
             </a:pPr>
             <a:r>
@@ -3208,9 +3208,9 @@
                 <a:solidFill>
                   <a:srgbClr val="5F6368"/>
                 </a:solidFill>
-                <a:latin typeface="PingFang SC"/>
-                <a:ea typeface="PingFang SC"/>
-                <a:cs typeface="PingFang SC"/>
+                <a:latin typeface="Microsoft YaHei"/>
+                <a:ea typeface="Microsoft YaHei"/>
+                <a:cs typeface="Microsoft YaHei"/>
               </a:defRPr>
             </a:pPr>
             <a:r>
@@ -3253,9 +3253,9 @@
                 <a:solidFill>
                   <a:srgbClr val="5F6368"/>
                 </a:solidFill>
-                <a:latin typeface="PingFang SC"/>
-                <a:ea typeface="PingFang SC"/>
-                <a:cs typeface="PingFang SC"/>
+                <a:latin typeface="Microsoft YaHei"/>
+                <a:ea typeface="Microsoft YaHei"/>
+                <a:cs typeface="Microsoft YaHei"/>
               </a:defRPr>
             </a:pPr>
             <a:r>
@@ -3327,9 +3327,9 @@
                 <a:solidFill>
                   <a:srgbClr val="3D8DFF"/>
                 </a:solidFill>
-                <a:latin typeface="PingFang SC"/>
-                <a:ea typeface="PingFang SC"/>
-                <a:cs typeface="PingFang SC"/>
+                <a:latin typeface="Microsoft YaHei"/>
+                <a:ea typeface="Microsoft YaHei"/>
+                <a:cs typeface="Microsoft YaHei"/>
               </a:defRPr>
             </a:pPr>
             <a:r>
@@ -3372,9 +3372,9 @@
                 <a:solidFill>
                   <a:srgbClr val="050505"/>
                 </a:solidFill>
-                <a:latin typeface="PingFang SC"/>
-                <a:ea typeface="PingFang SC"/>
-                <a:cs typeface="PingFang SC"/>
+                <a:latin typeface="Microsoft YaHei"/>
+                <a:ea typeface="Microsoft YaHei"/>
+                <a:cs typeface="Microsoft YaHei"/>
               </a:defRPr>
             </a:pPr>
             <a:r>
@@ -3417,9 +3417,9 @@
                 <a:solidFill>
                   <a:srgbClr val="5F6368"/>
                 </a:solidFill>
-                <a:latin typeface="PingFang SC"/>
-                <a:ea typeface="PingFang SC"/>
-                <a:cs typeface="PingFang SC"/>
+                <a:latin typeface="Microsoft YaHei"/>
+                <a:ea typeface="Microsoft YaHei"/>
+                <a:cs typeface="Microsoft YaHei"/>
               </a:defRPr>
             </a:pPr>
             <a:r>
@@ -3462,9 +3462,9 @@
                 <a:solidFill>
                   <a:srgbClr val="5F6368"/>
                 </a:solidFill>
-                <a:latin typeface="PingFang SC"/>
-                <a:ea typeface="PingFang SC"/>
-                <a:cs typeface="PingFang SC"/>
+                <a:latin typeface="Microsoft YaHei"/>
+                <a:ea typeface="Microsoft YaHei"/>
+                <a:cs typeface="Microsoft YaHei"/>
               </a:defRPr>
             </a:pPr>
             <a:r>
@@ -3612,9 +3612,9 @@
                 <a:solidFill>
                   <a:srgbClr val="050505"/>
                 </a:solidFill>
-                <a:latin typeface="PingFang SC"/>
-                <a:ea typeface="PingFang SC"/>
-                <a:cs typeface="PingFang SC"/>
+                <a:latin typeface="Microsoft YaHei"/>
+                <a:ea typeface="Microsoft YaHei"/>
+                <a:cs typeface="Microsoft YaHei"/>
               </a:defRPr>
             </a:pPr>
             <a:r>
@@ -3658,9 +3658,9 @@
                 <a:solidFill>
                   <a:srgbClr val="050505"/>
                 </a:solidFill>
-                <a:latin typeface="PingFang SC"/>
-                <a:ea typeface="PingFang SC"/>
-                <a:cs typeface="PingFang SC"/>
+                <a:latin typeface="Microsoft YaHei"/>
+                <a:ea typeface="Microsoft YaHei"/>
+                <a:cs typeface="Microsoft YaHei"/>
               </a:defRPr>
             </a:pPr>
             <a:r>
@@ -3704,9 +3704,9 @@
                 <a:solidFill>
                   <a:srgbClr val="050505"/>
                 </a:solidFill>
-                <a:latin typeface="PingFang SC"/>
-                <a:ea typeface="PingFang SC"/>
-                <a:cs typeface="PingFang SC"/>
+                <a:latin typeface="Microsoft YaHei"/>
+                <a:ea typeface="Microsoft YaHei"/>
+                <a:cs typeface="Microsoft YaHei"/>
               </a:defRPr>
             </a:pPr>
             <a:r>
@@ -3750,9 +3750,9 @@
                 <a:solidFill>
                   <a:srgbClr val="3D8DFF"/>
                 </a:solidFill>
-                <a:latin typeface="PingFang SC"/>
-                <a:ea typeface="PingFang SC"/>
-                <a:cs typeface="PingFang SC"/>
+                <a:latin typeface="Microsoft YaHei"/>
+                <a:ea typeface="Microsoft YaHei"/>
+                <a:cs typeface="Microsoft YaHei"/>
               </a:defRPr>
             </a:pPr>
             <a:r>
@@ -3830,9 +3830,9 @@
                 <a:solidFill>
                   <a:srgbClr val="5F6368"/>
                 </a:solidFill>
-                <a:latin typeface="PingFang SC"/>
-                <a:ea typeface="PingFang SC"/>
-                <a:cs typeface="PingFang SC"/>
+                <a:latin typeface="Microsoft YaHei"/>
+                <a:ea typeface="Microsoft YaHei"/>
+                <a:cs typeface="Microsoft YaHei"/>
               </a:defRPr>
             </a:pPr>
             <a:r>
@@ -4050,9 +4050,9 @@
                 <a:solidFill>
                   <a:srgbClr val="050505"/>
                 </a:solidFill>
-                <a:latin typeface="PingFang SC"/>
-                <a:ea typeface="PingFang SC"/>
-                <a:cs typeface="PingFang SC"/>
+                <a:latin typeface="Microsoft YaHei"/>
+                <a:ea typeface="Microsoft YaHei"/>
+                <a:cs typeface="Microsoft YaHei"/>
               </a:defRPr>
             </a:pPr>
             <a:r>
@@ -4095,9 +4095,9 @@
                 <a:solidFill>
                   <a:srgbClr val="5F6368"/>
                 </a:solidFill>
-                <a:latin typeface="PingFang SC"/>
-                <a:ea typeface="PingFang SC"/>
-                <a:cs typeface="PingFang SC"/>
+                <a:latin typeface="Microsoft YaHei"/>
+                <a:ea typeface="Microsoft YaHei"/>
+                <a:cs typeface="Microsoft YaHei"/>
               </a:defRPr>
             </a:pPr>
             <a:r>
@@ -4140,9 +4140,9 @@
                 <a:solidFill>
                   <a:srgbClr val="050505"/>
                 </a:solidFill>
-                <a:latin typeface="PingFang SC"/>
-                <a:ea typeface="PingFang SC"/>
-                <a:cs typeface="PingFang SC"/>
+                <a:latin typeface="Microsoft YaHei"/>
+                <a:ea typeface="Microsoft YaHei"/>
+                <a:cs typeface="Microsoft YaHei"/>
               </a:defRPr>
             </a:pPr>
             <a:r>
@@ -4185,9 +4185,9 @@
                 <a:solidFill>
                   <a:srgbClr val="5F6368"/>
                 </a:solidFill>
-                <a:latin typeface="PingFang SC"/>
-                <a:ea typeface="PingFang SC"/>
-                <a:cs typeface="PingFang SC"/>
+                <a:latin typeface="Microsoft YaHei"/>
+                <a:ea typeface="Microsoft YaHei"/>
+                <a:cs typeface="Microsoft YaHei"/>
               </a:defRPr>
             </a:pPr>
             <a:r>
@@ -4230,9 +4230,9 @@
                 <a:solidFill>
                   <a:srgbClr val="050505"/>
                 </a:solidFill>
-                <a:latin typeface="PingFang SC"/>
-                <a:ea typeface="PingFang SC"/>
-                <a:cs typeface="PingFang SC"/>
+                <a:latin typeface="Microsoft YaHei"/>
+                <a:ea typeface="Microsoft YaHei"/>
+                <a:cs typeface="Microsoft YaHei"/>
               </a:defRPr>
             </a:pPr>
             <a:r>
@@ -4275,9 +4275,9 @@
                 <a:solidFill>
                   <a:srgbClr val="5F6368"/>
                 </a:solidFill>
-                <a:latin typeface="PingFang SC"/>
-                <a:ea typeface="PingFang SC"/>
-                <a:cs typeface="PingFang SC"/>
+                <a:latin typeface="Microsoft YaHei"/>
+                <a:ea typeface="Microsoft YaHei"/>
+                <a:cs typeface="Microsoft YaHei"/>
               </a:defRPr>
             </a:pPr>
             <a:r>
@@ -4320,9 +4320,9 @@
                 <a:solidFill>
                   <a:srgbClr val="13233A"/>
                 </a:solidFill>
-                <a:latin typeface="PingFang SC"/>
-                <a:ea typeface="PingFang SC"/>
-                <a:cs typeface="PingFang SC"/>
+                <a:latin typeface="Microsoft YaHei"/>
+                <a:ea typeface="Microsoft YaHei"/>
+                <a:cs typeface="Microsoft YaHei"/>
               </a:defRPr>
             </a:pPr>
             <a:r>
@@ -4365,9 +4365,9 @@
                 <a:solidFill>
                   <a:srgbClr val="5F6368"/>
                 </a:solidFill>
-                <a:latin typeface="PingFang SC"/>
-                <a:ea typeface="PingFang SC"/>
-                <a:cs typeface="PingFang SC"/>
+                <a:latin typeface="Microsoft YaHei"/>
+                <a:ea typeface="Microsoft YaHei"/>
+                <a:cs typeface="Microsoft YaHei"/>
               </a:defRPr>
             </a:pPr>
             <a:r>
@@ -4410,9 +4410,9 @@
                 <a:solidFill>
                   <a:srgbClr val="13233A"/>
                 </a:solidFill>
-                <a:latin typeface="PingFang SC"/>
-                <a:ea typeface="PingFang SC"/>
-                <a:cs typeface="PingFang SC"/>
+                <a:latin typeface="Microsoft YaHei"/>
+                <a:ea typeface="Microsoft YaHei"/>
+                <a:cs typeface="Microsoft YaHei"/>
               </a:defRPr>
             </a:pPr>
             <a:r>
@@ -4455,9 +4455,9 @@
                 <a:solidFill>
                   <a:srgbClr val="5F6368"/>
                 </a:solidFill>
-                <a:latin typeface="PingFang SC"/>
-                <a:ea typeface="PingFang SC"/>
-                <a:cs typeface="PingFang SC"/>
+                <a:latin typeface="Microsoft YaHei"/>
+                <a:ea typeface="Microsoft YaHei"/>
+                <a:cs typeface="Microsoft YaHei"/>
               </a:defRPr>
             </a:pPr>
             <a:r>
@@ -4500,9 +4500,9 @@
                 <a:solidFill>
                   <a:srgbClr val="3D8DFF"/>
                 </a:solidFill>
-                <a:latin typeface="PingFang SC"/>
-                <a:ea typeface="PingFang SC"/>
-                <a:cs typeface="PingFang SC"/>
+                <a:latin typeface="Microsoft YaHei"/>
+                <a:ea typeface="Microsoft YaHei"/>
+                <a:cs typeface="Microsoft YaHei"/>
               </a:defRPr>
             </a:pPr>
             <a:r>
@@ -4545,9 +4545,9 @@
                 <a:solidFill>
                   <a:srgbClr val="3D8DFF"/>
                 </a:solidFill>
-                <a:latin typeface="PingFang SC"/>
-                <a:ea typeface="PingFang SC"/>
-                <a:cs typeface="PingFang SC"/>
+                <a:latin typeface="Microsoft YaHei"/>
+                <a:ea typeface="Microsoft YaHei"/>
+                <a:cs typeface="Microsoft YaHei"/>
               </a:defRPr>
             </a:pPr>
             <a:r>
@@ -4590,9 +4590,9 @@
                 <a:solidFill>
                   <a:srgbClr val="3D8DFF"/>
                 </a:solidFill>
-                <a:latin typeface="PingFang SC"/>
-                <a:ea typeface="PingFang SC"/>
-                <a:cs typeface="PingFang SC"/>
+                <a:latin typeface="Microsoft YaHei"/>
+                <a:ea typeface="Microsoft YaHei"/>
+                <a:cs typeface="Microsoft YaHei"/>
               </a:defRPr>
             </a:pPr>
             <a:r>
@@ -4635,9 +4635,9 @@
                 <a:solidFill>
                   <a:srgbClr val="3D8DFF"/>
                 </a:solidFill>
-                <a:latin typeface="PingFang SC"/>
-                <a:ea typeface="PingFang SC"/>
-                <a:cs typeface="PingFang SC"/>
+                <a:latin typeface="Microsoft YaHei"/>
+                <a:ea typeface="Microsoft YaHei"/>
+                <a:cs typeface="Microsoft YaHei"/>
               </a:defRPr>
             </a:pPr>
             <a:r>
@@ -4680,9 +4680,9 @@
                 <a:solidFill>
                   <a:srgbClr val="3D8DFF"/>
                 </a:solidFill>
-                <a:latin typeface="PingFang SC"/>
-                <a:ea typeface="PingFang SC"/>
-                <a:cs typeface="PingFang SC"/>
+                <a:latin typeface="Microsoft YaHei"/>
+                <a:ea typeface="Microsoft YaHei"/>
+                <a:cs typeface="Microsoft YaHei"/>
               </a:defRPr>
             </a:pPr>
             <a:r>
@@ -4725,9 +4725,9 @@
                 <a:solidFill>
                   <a:srgbClr val="3D8DFF"/>
                 </a:solidFill>
-                <a:latin typeface="PingFang SC"/>
-                <a:ea typeface="PingFang SC"/>
-                <a:cs typeface="PingFang SC"/>
+                <a:latin typeface="Microsoft YaHei"/>
+                <a:ea typeface="Microsoft YaHei"/>
+                <a:cs typeface="Microsoft YaHei"/>
               </a:defRPr>
             </a:pPr>
             <a:r>
@@ -4770,9 +4770,9 @@
                 <a:solidFill>
                   <a:srgbClr val="5F6368"/>
                 </a:solidFill>
-                <a:latin typeface="PingFang SC"/>
-                <a:ea typeface="PingFang SC"/>
-                <a:cs typeface="PingFang SC"/>
+                <a:latin typeface="Microsoft YaHei"/>
+                <a:ea typeface="Microsoft YaHei"/>
+                <a:cs typeface="Microsoft YaHei"/>
               </a:defRPr>
             </a:pPr>
             <a:r>
@@ -4815,9 +4815,9 @@
                 <a:solidFill>
                   <a:srgbClr val="050505"/>
                 </a:solidFill>
-                <a:latin typeface="PingFang SC"/>
-                <a:ea typeface="PingFang SC"/>
-                <a:cs typeface="PingFang SC"/>
+                <a:latin typeface="Microsoft YaHei"/>
+                <a:ea typeface="Microsoft YaHei"/>
+                <a:cs typeface="Microsoft YaHei"/>
               </a:defRPr>
             </a:pPr>
             <a:r>
@@ -4900,9 +4900,9 @@
                 <a:solidFill>
                   <a:srgbClr val="FFFFFF"/>
                 </a:solidFill>
-                <a:latin typeface="PingFang SC"/>
-                <a:ea typeface="PingFang SC"/>
-                <a:cs typeface="PingFang SC"/>
+                <a:latin typeface="Microsoft YaHei"/>
+                <a:ea typeface="Microsoft YaHei"/>
+                <a:cs typeface="Microsoft YaHei"/>
               </a:defRPr>
             </a:pPr>
             <a:r>
@@ -4978,9 +4978,9 @@
                 <a:solidFill>
                   <a:srgbClr val="5F6368"/>
                 </a:solidFill>
-                <a:latin typeface="PingFang SC"/>
-                <a:ea typeface="PingFang SC"/>
-                <a:cs typeface="PingFang SC"/>
+                <a:latin typeface="Microsoft YaHei"/>
+                <a:ea typeface="Microsoft YaHei"/>
+                <a:cs typeface="Microsoft YaHei"/>
               </a:defRPr>
             </a:pPr>
             <a:r>
@@ -5023,9 +5023,9 @@
                 <a:solidFill>
                   <a:srgbClr val="5F6368"/>
                 </a:solidFill>
-                <a:latin typeface="PingFang SC"/>
-                <a:ea typeface="PingFang SC"/>
-                <a:cs typeface="PingFang SC"/>
+                <a:latin typeface="Microsoft YaHei"/>
+                <a:ea typeface="Microsoft YaHei"/>
+                <a:cs typeface="Microsoft YaHei"/>
               </a:defRPr>
             </a:pPr>
             <a:r>
@@ -5097,9 +5097,9 @@
                 <a:solidFill>
                   <a:srgbClr val="3D8DFF"/>
                 </a:solidFill>
-                <a:latin typeface="PingFang SC"/>
-                <a:ea typeface="PingFang SC"/>
-                <a:cs typeface="PingFang SC"/>
+                <a:latin typeface="Microsoft YaHei"/>
+                <a:ea typeface="Microsoft YaHei"/>
+                <a:cs typeface="Microsoft YaHei"/>
               </a:defRPr>
             </a:pPr>
             <a:r>
@@ -5142,9 +5142,9 @@
                 <a:solidFill>
                   <a:srgbClr val="050505"/>
                 </a:solidFill>
-                <a:latin typeface="PingFang SC"/>
-                <a:ea typeface="PingFang SC"/>
-                <a:cs typeface="PingFang SC"/>
+                <a:latin typeface="Microsoft YaHei"/>
+                <a:ea typeface="Microsoft YaHei"/>
+                <a:cs typeface="Microsoft YaHei"/>
               </a:defRPr>
             </a:pPr>
             <a:r>
@@ -5187,9 +5187,9 @@
                 <a:solidFill>
                   <a:srgbClr val="5F6368"/>
                 </a:solidFill>
-                <a:latin typeface="PingFang SC"/>
-                <a:ea typeface="PingFang SC"/>
-                <a:cs typeface="PingFang SC"/>
+                <a:latin typeface="Microsoft YaHei"/>
+                <a:ea typeface="Microsoft YaHei"/>
+                <a:cs typeface="Microsoft YaHei"/>
               </a:defRPr>
             </a:pPr>
             <a:r>
@@ -5294,9 +5294,9 @@
                 <a:solidFill>
                   <a:srgbClr val="13233A"/>
                 </a:solidFill>
-                <a:latin typeface="PingFang SC"/>
-                <a:ea typeface="PingFang SC"/>
-                <a:cs typeface="PingFang SC"/>
+                <a:latin typeface="Microsoft YaHei"/>
+                <a:ea typeface="Microsoft YaHei"/>
+                <a:cs typeface="Microsoft YaHei"/>
               </a:defRPr>
             </a:pPr>
             <a:r>
@@ -5374,9 +5374,9 @@
                 <a:solidFill>
                   <a:srgbClr val="5F6368"/>
                 </a:solidFill>
-                <a:latin typeface="PingFang SC"/>
-                <a:ea typeface="PingFang SC"/>
-                <a:cs typeface="PingFang SC"/>
+                <a:latin typeface="Microsoft YaHei"/>
+                <a:ea typeface="Microsoft YaHei"/>
+                <a:cs typeface="Microsoft YaHei"/>
               </a:defRPr>
             </a:pPr>
             <a:r>
@@ -5419,9 +5419,9 @@
                 <a:solidFill>
                   <a:srgbClr val="050505"/>
                 </a:solidFill>
-                <a:latin typeface="PingFang SC"/>
-                <a:ea typeface="PingFang SC"/>
-                <a:cs typeface="PingFang SC"/>
+                <a:latin typeface="Microsoft YaHei"/>
+                <a:ea typeface="Microsoft YaHei"/>
+                <a:cs typeface="Microsoft YaHei"/>
               </a:defRPr>
             </a:pPr>
             <a:r>
@@ -5464,9 +5464,9 @@
                 <a:solidFill>
                   <a:srgbClr val="3D8DFF"/>
                 </a:solidFill>
-                <a:latin typeface="PingFang SC"/>
-                <a:ea typeface="PingFang SC"/>
-                <a:cs typeface="PingFang SC"/>
+                <a:latin typeface="Microsoft YaHei"/>
+                <a:ea typeface="Microsoft YaHei"/>
+                <a:cs typeface="Microsoft YaHei"/>
               </a:defRPr>
             </a:pPr>
             <a:r>
@@ -5509,9 +5509,9 @@
                 <a:solidFill>
                   <a:srgbClr val="5F6368"/>
                 </a:solidFill>
-                <a:latin typeface="PingFang SC"/>
-                <a:ea typeface="PingFang SC"/>
-                <a:cs typeface="PingFang SC"/>
+                <a:latin typeface="Microsoft YaHei"/>
+                <a:ea typeface="Microsoft YaHei"/>
+                <a:cs typeface="Microsoft YaHei"/>
               </a:defRPr>
             </a:pPr>
             <a:r>
@@ -5659,9 +5659,9 @@
                 <a:solidFill>
                   <a:srgbClr val="F35B62"/>
                 </a:solidFill>
-                <a:latin typeface="PingFang SC"/>
-                <a:ea typeface="PingFang SC"/>
-                <a:cs typeface="PingFang SC"/>
+                <a:latin typeface="Microsoft YaHei"/>
+                <a:ea typeface="Microsoft YaHei"/>
+                <a:cs typeface="Microsoft YaHei"/>
               </a:defRPr>
             </a:pPr>
             <a:r>
@@ -5704,9 +5704,9 @@
                 <a:solidFill>
                   <a:srgbClr val="050505"/>
                 </a:solidFill>
-                <a:latin typeface="PingFang SC"/>
-                <a:ea typeface="PingFang SC"/>
-                <a:cs typeface="PingFang SC"/>
+                <a:latin typeface="Microsoft YaHei"/>
+                <a:ea typeface="Microsoft YaHei"/>
+                <a:cs typeface="Microsoft YaHei"/>
               </a:defRPr>
             </a:pPr>
             <a:r>
@@ -5749,9 +5749,9 @@
                 <a:solidFill>
                   <a:srgbClr val="F35B62"/>
                 </a:solidFill>
-                <a:latin typeface="PingFang SC"/>
-                <a:ea typeface="PingFang SC"/>
-                <a:cs typeface="PingFang SC"/>
+                <a:latin typeface="Microsoft YaHei"/>
+                <a:ea typeface="Microsoft YaHei"/>
+                <a:cs typeface="Microsoft YaHei"/>
               </a:defRPr>
             </a:pPr>
             <a:r>
@@ -5794,9 +5794,9 @@
                 <a:solidFill>
                   <a:srgbClr val="050505"/>
                 </a:solidFill>
-                <a:latin typeface="PingFang SC"/>
-                <a:ea typeface="PingFang SC"/>
-                <a:cs typeface="PingFang SC"/>
+                <a:latin typeface="Microsoft YaHei"/>
+                <a:ea typeface="Microsoft YaHei"/>
+                <a:cs typeface="Microsoft YaHei"/>
               </a:defRPr>
             </a:pPr>
             <a:r>
@@ -5839,9 +5839,9 @@
                 <a:solidFill>
                   <a:srgbClr val="F35B62"/>
                 </a:solidFill>
-                <a:latin typeface="PingFang SC"/>
-                <a:ea typeface="PingFang SC"/>
-                <a:cs typeface="PingFang SC"/>
+                <a:latin typeface="Microsoft YaHei"/>
+                <a:ea typeface="Microsoft YaHei"/>
+                <a:cs typeface="Microsoft YaHei"/>
               </a:defRPr>
             </a:pPr>
             <a:r>
@@ -5884,9 +5884,9 @@
                 <a:solidFill>
                   <a:srgbClr val="050505"/>
                 </a:solidFill>
-                <a:latin typeface="PingFang SC"/>
-                <a:ea typeface="PingFang SC"/>
-                <a:cs typeface="PingFang SC"/>
+                <a:latin typeface="Microsoft YaHei"/>
+                <a:ea typeface="Microsoft YaHei"/>
+                <a:cs typeface="Microsoft YaHei"/>
               </a:defRPr>
             </a:pPr>
             <a:r>
@@ -5964,9 +5964,9 @@
                 <a:solidFill>
                   <a:srgbClr val="FFFFFF"/>
                 </a:solidFill>
-                <a:latin typeface="PingFang SC"/>
-                <a:ea typeface="PingFang SC"/>
-                <a:cs typeface="PingFang SC"/>
+                <a:latin typeface="Microsoft YaHei"/>
+                <a:ea typeface="Microsoft YaHei"/>
+                <a:cs typeface="Microsoft YaHei"/>
               </a:defRPr>
             </a:pPr>
             <a:r>
@@ -6009,9 +6009,9 @@
                 <a:solidFill>
                   <a:srgbClr val="FFFFFF"/>
                 </a:solidFill>
-                <a:latin typeface="PingFang SC"/>
-                <a:ea typeface="PingFang SC"/>
-                <a:cs typeface="PingFang SC"/>
+                <a:latin typeface="Microsoft YaHei"/>
+                <a:ea typeface="Microsoft YaHei"/>
+                <a:cs typeface="Microsoft YaHei"/>
               </a:defRPr>
             </a:pPr>
             <a:r>
@@ -6054,9 +6054,9 @@
                 <a:solidFill>
                   <a:srgbClr val="FFFFFF"/>
                 </a:solidFill>
-                <a:latin typeface="PingFang SC"/>
-                <a:ea typeface="PingFang SC"/>
-                <a:cs typeface="PingFang SC"/>
+                <a:latin typeface="Microsoft YaHei"/>
+                <a:ea typeface="Microsoft YaHei"/>
+                <a:cs typeface="Microsoft YaHei"/>
               </a:defRPr>
             </a:pPr>
             <a:r>
@@ -6134,9 +6134,9 @@
                 <a:solidFill>
                   <a:srgbClr val="13233A"/>
                 </a:solidFill>
-                <a:latin typeface="PingFang SC"/>
-                <a:ea typeface="PingFang SC"/>
-                <a:cs typeface="PingFang SC"/>
+                <a:latin typeface="Microsoft YaHei"/>
+                <a:ea typeface="Microsoft YaHei"/>
+                <a:cs typeface="Microsoft YaHei"/>
               </a:defRPr>
             </a:pPr>
             <a:r>
@@ -6212,9 +6212,9 @@
                 <a:solidFill>
                   <a:srgbClr val="5F6368"/>
                 </a:solidFill>
-                <a:latin typeface="PingFang SC"/>
-                <a:ea typeface="PingFang SC"/>
-                <a:cs typeface="PingFang SC"/>
+                <a:latin typeface="Microsoft YaHei"/>
+                <a:ea typeface="Microsoft YaHei"/>
+                <a:cs typeface="Microsoft YaHei"/>
               </a:defRPr>
             </a:pPr>
             <a:r>
@@ -6257,9 +6257,9 @@
                 <a:solidFill>
                   <a:srgbClr val="5F6368"/>
                 </a:solidFill>
-                <a:latin typeface="PingFang SC"/>
-                <a:ea typeface="PingFang SC"/>
-                <a:cs typeface="PingFang SC"/>
+                <a:latin typeface="Microsoft YaHei"/>
+                <a:ea typeface="Microsoft YaHei"/>
+                <a:cs typeface="Microsoft YaHei"/>
               </a:defRPr>
             </a:pPr>
             <a:r>
@@ -6331,9 +6331,9 @@
                 <a:solidFill>
                   <a:srgbClr val="3D8DFF"/>
                 </a:solidFill>
-                <a:latin typeface="PingFang SC"/>
-                <a:ea typeface="PingFang SC"/>
-                <a:cs typeface="PingFang SC"/>
+                <a:latin typeface="Microsoft YaHei"/>
+                <a:ea typeface="Microsoft YaHei"/>
+                <a:cs typeface="Microsoft YaHei"/>
               </a:defRPr>
             </a:pPr>
             <a:r>
@@ -6376,9 +6376,9 @@
                 <a:solidFill>
                   <a:srgbClr val="050505"/>
                 </a:solidFill>
-                <a:latin typeface="PingFang SC"/>
-                <a:ea typeface="PingFang SC"/>
-                <a:cs typeface="PingFang SC"/>
+                <a:latin typeface="Microsoft YaHei"/>
+                <a:ea typeface="Microsoft YaHei"/>
+                <a:cs typeface="Microsoft YaHei"/>
               </a:defRPr>
             </a:pPr>
             <a:r>
@@ -6421,9 +6421,9 @@
                 <a:solidFill>
                   <a:srgbClr val="5F6368"/>
                 </a:solidFill>
-                <a:latin typeface="PingFang SC"/>
-                <a:ea typeface="PingFang SC"/>
-                <a:cs typeface="PingFang SC"/>
+                <a:latin typeface="Microsoft YaHei"/>
+                <a:ea typeface="Microsoft YaHei"/>
+                <a:cs typeface="Microsoft YaHei"/>
               </a:defRPr>
             </a:pPr>
             <a:r>
@@ -6571,9 +6571,9 @@
                 <a:solidFill>
                   <a:srgbClr val="050505"/>
                 </a:solidFill>
-                <a:latin typeface="PingFang SC"/>
-                <a:ea typeface="PingFang SC"/>
-                <a:cs typeface="PingFang SC"/>
+                <a:latin typeface="Microsoft YaHei"/>
+                <a:ea typeface="Microsoft YaHei"/>
+                <a:cs typeface="Microsoft YaHei"/>
               </a:defRPr>
             </a:pPr>
             <a:r>
@@ -6616,9 +6616,9 @@
                 <a:solidFill>
                   <a:srgbClr val="5F6368"/>
                 </a:solidFill>
-                <a:latin typeface="PingFang SC"/>
-                <a:ea typeface="PingFang SC"/>
-                <a:cs typeface="PingFang SC"/>
+                <a:latin typeface="Microsoft YaHei"/>
+                <a:ea typeface="Microsoft YaHei"/>
+                <a:cs typeface="Microsoft YaHei"/>
               </a:defRPr>
             </a:pPr>
             <a:r>
@@ -6661,9 +6661,9 @@
                 <a:solidFill>
                   <a:srgbClr val="050505"/>
                 </a:solidFill>
-                <a:latin typeface="PingFang SC"/>
-                <a:ea typeface="PingFang SC"/>
-                <a:cs typeface="PingFang SC"/>
+                <a:latin typeface="Microsoft YaHei"/>
+                <a:ea typeface="Microsoft YaHei"/>
+                <a:cs typeface="Microsoft YaHei"/>
               </a:defRPr>
             </a:pPr>
             <a:r>
@@ -6706,9 +6706,9 @@
                 <a:solidFill>
                   <a:srgbClr val="5F6368"/>
                 </a:solidFill>
-                <a:latin typeface="PingFang SC"/>
-                <a:ea typeface="PingFang SC"/>
-                <a:cs typeface="PingFang SC"/>
+                <a:latin typeface="Microsoft YaHei"/>
+                <a:ea typeface="Microsoft YaHei"/>
+                <a:cs typeface="Microsoft YaHei"/>
               </a:defRPr>
             </a:pPr>
             <a:r>
@@ -6751,9 +6751,9 @@
                 <a:solidFill>
                   <a:srgbClr val="050505"/>
                 </a:solidFill>
-                <a:latin typeface="PingFang SC"/>
-                <a:ea typeface="PingFang SC"/>
-                <a:cs typeface="PingFang SC"/>
+                <a:latin typeface="Microsoft YaHei"/>
+                <a:ea typeface="Microsoft YaHei"/>
+                <a:cs typeface="Microsoft YaHei"/>
               </a:defRPr>
             </a:pPr>
             <a:r>
@@ -6796,9 +6796,9 @@
                 <a:solidFill>
                   <a:srgbClr val="5F6368"/>
                 </a:solidFill>
-                <a:latin typeface="PingFang SC"/>
-                <a:ea typeface="PingFang SC"/>
-                <a:cs typeface="PingFang SC"/>
+                <a:latin typeface="Microsoft YaHei"/>
+                <a:ea typeface="Microsoft YaHei"/>
+                <a:cs typeface="Microsoft YaHei"/>
               </a:defRPr>
             </a:pPr>
             <a:r>
@@ -6868,9 +6868,9 @@
                 <a:solidFill>
                   <a:srgbClr val="5F6368"/>
                 </a:solidFill>
-                <a:latin typeface="PingFang SC"/>
-                <a:ea typeface="PingFang SC"/>
-                <a:cs typeface="PingFang SC"/>
+                <a:latin typeface="Microsoft YaHei"/>
+                <a:ea typeface="Microsoft YaHei"/>
+                <a:cs typeface="Microsoft YaHei"/>
               </a:defRPr>
             </a:pPr>
             <a:r>
@@ -6948,9 +6948,9 @@
                 <a:solidFill>
                   <a:srgbClr val="FFFFFF"/>
                 </a:solidFill>
-                <a:latin typeface="PingFang SC"/>
-                <a:ea typeface="PingFang SC"/>
-                <a:cs typeface="PingFang SC"/>
+                <a:latin typeface="Microsoft YaHei"/>
+                <a:ea typeface="Microsoft YaHei"/>
+                <a:cs typeface="Microsoft YaHei"/>
               </a:defRPr>
             </a:pPr>
             <a:r>
@@ -6993,9 +6993,9 @@
                 <a:solidFill>
                   <a:srgbClr val="FFFFFF"/>
                 </a:solidFill>
-                <a:latin typeface="PingFang SC"/>
-                <a:ea typeface="PingFang SC"/>
-                <a:cs typeface="PingFang SC"/>
+                <a:latin typeface="Microsoft YaHei"/>
+                <a:ea typeface="Microsoft YaHei"/>
+                <a:cs typeface="Microsoft YaHei"/>
               </a:defRPr>
             </a:pPr>
             <a:r>
@@ -7038,9 +7038,9 @@
                 <a:solidFill>
                   <a:srgbClr val="FFFFFF"/>
                 </a:solidFill>
-                <a:latin typeface="PingFang SC"/>
-                <a:ea typeface="PingFang SC"/>
-                <a:cs typeface="PingFang SC"/>
+                <a:latin typeface="Microsoft YaHei"/>
+                <a:ea typeface="Microsoft YaHei"/>
+                <a:cs typeface="Microsoft YaHei"/>
               </a:defRPr>
             </a:pPr>
             <a:r>
@@ -7083,9 +7083,9 @@
                 <a:solidFill>
                   <a:srgbClr val="3D8DFF"/>
                 </a:solidFill>
-                <a:latin typeface="PingFang SC"/>
-                <a:ea typeface="PingFang SC"/>
-                <a:cs typeface="PingFang SC"/>
+                <a:latin typeface="Microsoft YaHei"/>
+                <a:ea typeface="Microsoft YaHei"/>
+                <a:cs typeface="Microsoft YaHei"/>
               </a:defRPr>
             </a:pPr>
             <a:r>
@@ -7233,9 +7233,9 @@
                 <a:solidFill>
                   <a:srgbClr val="3D8DFF"/>
                 </a:solidFill>
-                <a:latin typeface="PingFang SC"/>
-                <a:ea typeface="PingFang SC"/>
-                <a:cs typeface="PingFang SC"/>
+                <a:latin typeface="Microsoft YaHei"/>
+                <a:ea typeface="Microsoft YaHei"/>
+                <a:cs typeface="Microsoft YaHei"/>
               </a:defRPr>
             </a:pPr>
             <a:r>
@@ -7278,9 +7278,9 @@
                 <a:solidFill>
                   <a:srgbClr val="050505"/>
                 </a:solidFill>
-                <a:latin typeface="PingFang SC"/>
-                <a:ea typeface="PingFang SC"/>
-                <a:cs typeface="PingFang SC"/>
+                <a:latin typeface="Microsoft YaHei"/>
+                <a:ea typeface="Microsoft YaHei"/>
+                <a:cs typeface="Microsoft YaHei"/>
               </a:defRPr>
             </a:pPr>
             <a:r>
@@ -7323,9 +7323,9 @@
                 <a:solidFill>
                   <a:srgbClr val="5F6368"/>
                 </a:solidFill>
-                <a:latin typeface="PingFang SC"/>
-                <a:ea typeface="PingFang SC"/>
-                <a:cs typeface="PingFang SC"/>
+                <a:latin typeface="Microsoft YaHei"/>
+                <a:ea typeface="Microsoft YaHei"/>
+                <a:cs typeface="Microsoft YaHei"/>
               </a:defRPr>
             </a:pPr>
             <a:r>
@@ -7368,9 +7368,9 @@
                 <a:solidFill>
                   <a:srgbClr val="3D8DFF"/>
                 </a:solidFill>
-                <a:latin typeface="PingFang SC"/>
-                <a:ea typeface="PingFang SC"/>
-                <a:cs typeface="PingFang SC"/>
+                <a:latin typeface="Microsoft YaHei"/>
+                <a:ea typeface="Microsoft YaHei"/>
+                <a:cs typeface="Microsoft YaHei"/>
               </a:defRPr>
             </a:pPr>
             <a:r>
@@ -7413,9 +7413,9 @@
                 <a:solidFill>
                   <a:srgbClr val="050505"/>
                 </a:solidFill>
-                <a:latin typeface="PingFang SC"/>
-                <a:ea typeface="PingFang SC"/>
-                <a:cs typeface="PingFang SC"/>
+                <a:latin typeface="Microsoft YaHei"/>
+                <a:ea typeface="Microsoft YaHei"/>
+                <a:cs typeface="Microsoft YaHei"/>
               </a:defRPr>
             </a:pPr>
             <a:r>
@@ -7458,9 +7458,9 @@
                 <a:solidFill>
                   <a:srgbClr val="5F6368"/>
                 </a:solidFill>
-                <a:latin typeface="PingFang SC"/>
-                <a:ea typeface="PingFang SC"/>
-                <a:cs typeface="PingFang SC"/>
+                <a:latin typeface="Microsoft YaHei"/>
+                <a:ea typeface="Microsoft YaHei"/>
+                <a:cs typeface="Microsoft YaHei"/>
               </a:defRPr>
             </a:pPr>
             <a:r>
@@ -7503,9 +7503,9 @@
                 <a:solidFill>
                   <a:srgbClr val="3D8DFF"/>
                 </a:solidFill>
-                <a:latin typeface="PingFang SC"/>
-                <a:ea typeface="PingFang SC"/>
-                <a:cs typeface="PingFang SC"/>
+                <a:latin typeface="Microsoft YaHei"/>
+                <a:ea typeface="Microsoft YaHei"/>
+                <a:cs typeface="Microsoft YaHei"/>
               </a:defRPr>
             </a:pPr>
             <a:r>
@@ -7548,9 +7548,9 @@
                 <a:solidFill>
                   <a:srgbClr val="050505"/>
                 </a:solidFill>
-                <a:latin typeface="PingFang SC"/>
-                <a:ea typeface="PingFang SC"/>
-                <a:cs typeface="PingFang SC"/>
+                <a:latin typeface="Microsoft YaHei"/>
+                <a:ea typeface="Microsoft YaHei"/>
+                <a:cs typeface="Microsoft YaHei"/>
               </a:defRPr>
             </a:pPr>
             <a:r>
@@ -7593,9 +7593,9 @@
                 <a:solidFill>
                   <a:srgbClr val="5F6368"/>
                 </a:solidFill>
-                <a:latin typeface="PingFang SC"/>
-                <a:ea typeface="PingFang SC"/>
-                <a:cs typeface="PingFang SC"/>
+                <a:latin typeface="Microsoft YaHei"/>
+                <a:ea typeface="Microsoft YaHei"/>
+                <a:cs typeface="Microsoft YaHei"/>
               </a:defRPr>
             </a:pPr>
             <a:r>
@@ -7673,9 +7673,9 @@
                 <a:solidFill>
                   <a:srgbClr val="13233A"/>
                 </a:solidFill>
-                <a:latin typeface="PingFang SC"/>
-                <a:ea typeface="PingFang SC"/>
-                <a:cs typeface="PingFang SC"/>
+                <a:latin typeface="Microsoft YaHei"/>
+                <a:ea typeface="Microsoft YaHei"/>
+                <a:cs typeface="Microsoft YaHei"/>
               </a:defRPr>
             </a:pPr>
             <a:r>
@@ -7751,9 +7751,9 @@
                 <a:solidFill>
                   <a:srgbClr val="5F6368"/>
                 </a:solidFill>
-                <a:latin typeface="PingFang SC"/>
-                <a:ea typeface="PingFang SC"/>
-                <a:cs typeface="PingFang SC"/>
+                <a:latin typeface="Microsoft YaHei"/>
+                <a:ea typeface="Microsoft YaHei"/>
+                <a:cs typeface="Microsoft YaHei"/>
               </a:defRPr>
             </a:pPr>
             <a:r>
@@ -7796,9 +7796,9 @@
                 <a:solidFill>
                   <a:srgbClr val="5F6368"/>
                 </a:solidFill>
-                <a:latin typeface="PingFang SC"/>
-                <a:ea typeface="PingFang SC"/>
-                <a:cs typeface="PingFang SC"/>
+                <a:latin typeface="Microsoft YaHei"/>
+                <a:ea typeface="Microsoft YaHei"/>
+                <a:cs typeface="Microsoft YaHei"/>
               </a:defRPr>
             </a:pPr>
             <a:r>
@@ -7870,9 +7870,9 @@
                 <a:solidFill>
                   <a:srgbClr val="3D8DFF"/>
                 </a:solidFill>
-                <a:latin typeface="PingFang SC"/>
-                <a:ea typeface="PingFang SC"/>
-                <a:cs typeface="PingFang SC"/>
+                <a:latin typeface="Microsoft YaHei"/>
+                <a:ea typeface="Microsoft YaHei"/>
+                <a:cs typeface="Microsoft YaHei"/>
               </a:defRPr>
             </a:pPr>
             <a:r>
@@ -7915,9 +7915,9 @@
                 <a:solidFill>
                   <a:srgbClr val="050505"/>
                 </a:solidFill>
-                <a:latin typeface="PingFang SC"/>
-                <a:ea typeface="PingFang SC"/>
-                <a:cs typeface="PingFang SC"/>
+                <a:latin typeface="Microsoft YaHei"/>
+                <a:ea typeface="Microsoft YaHei"/>
+                <a:cs typeface="Microsoft YaHei"/>
               </a:defRPr>
             </a:pPr>
             <a:r>
@@ -7960,9 +7960,9 @@
                 <a:solidFill>
                   <a:srgbClr val="5F6368"/>
                 </a:solidFill>
-                <a:latin typeface="PingFang SC"/>
-                <a:ea typeface="PingFang SC"/>
-                <a:cs typeface="PingFang SC"/>
+                <a:latin typeface="Microsoft YaHei"/>
+                <a:ea typeface="Microsoft YaHei"/>
+                <a:cs typeface="Microsoft YaHei"/>
               </a:defRPr>
             </a:pPr>
             <a:r>
@@ -8040,9 +8040,9 @@
                 <a:solidFill>
                   <a:srgbClr val="5F6368"/>
                 </a:solidFill>
-                <a:latin typeface="PingFang SC"/>
-                <a:ea typeface="PingFang SC"/>
-                <a:cs typeface="PingFang SC"/>
+                <a:latin typeface="Microsoft YaHei"/>
+                <a:ea typeface="Microsoft YaHei"/>
+                <a:cs typeface="Microsoft YaHei"/>
               </a:defRPr>
             </a:pPr>
             <a:r>
@@ -8085,9 +8085,9 @@
                 <a:solidFill>
                   <a:srgbClr val="050505"/>
                 </a:solidFill>
-                <a:latin typeface="PingFang SC"/>
-                <a:ea typeface="PingFang SC"/>
-                <a:cs typeface="PingFang SC"/>
+                <a:latin typeface="Microsoft YaHei"/>
+                <a:ea typeface="Microsoft YaHei"/>
+                <a:cs typeface="Microsoft YaHei"/>
               </a:defRPr>
             </a:pPr>
             <a:r>
@@ -8163,9 +8163,9 @@
                 <a:solidFill>
                   <a:srgbClr val="3D8DFF"/>
                 </a:solidFill>
-                <a:latin typeface="PingFang SC"/>
-                <a:ea typeface="PingFang SC"/>
-                <a:cs typeface="PingFang SC"/>
+                <a:latin typeface="Microsoft YaHei"/>
+                <a:ea typeface="Microsoft YaHei"/>
+                <a:cs typeface="Microsoft YaHei"/>
               </a:defRPr>
             </a:pPr>
             <a:r>
@@ -8208,9 +8208,9 @@
                 <a:solidFill>
                   <a:srgbClr val="5F6368"/>
                 </a:solidFill>
-                <a:latin typeface="PingFang SC"/>
-                <a:ea typeface="PingFang SC"/>
-                <a:cs typeface="PingFang SC"/>
+                <a:latin typeface="Microsoft YaHei"/>
+                <a:ea typeface="Microsoft YaHei"/>
+                <a:cs typeface="Microsoft YaHei"/>
               </a:defRPr>
             </a:pPr>
             <a:r>
@@ -8253,9 +8253,9 @@
                 <a:solidFill>
                   <a:srgbClr val="050505"/>
                 </a:solidFill>
-                <a:latin typeface="PingFang SC"/>
-                <a:ea typeface="PingFang SC"/>
-                <a:cs typeface="PingFang SC"/>
+                <a:latin typeface="Microsoft YaHei"/>
+                <a:ea typeface="Microsoft YaHei"/>
+                <a:cs typeface="Microsoft YaHei"/>
               </a:defRPr>
             </a:pPr>
             <a:r>
@@ -8298,9 +8298,9 @@
                 <a:solidFill>
                   <a:srgbClr val="5F6368"/>
                 </a:solidFill>
-                <a:latin typeface="PingFang SC"/>
-                <a:ea typeface="PingFang SC"/>
-                <a:cs typeface="PingFang SC"/>
+                <a:latin typeface="Microsoft YaHei"/>
+                <a:ea typeface="Microsoft YaHei"/>
+                <a:cs typeface="Microsoft YaHei"/>
               </a:defRPr>
             </a:pPr>
             <a:r>
@@ -8343,9 +8343,9 @@
                 <a:solidFill>
                   <a:srgbClr val="3D8DFF"/>
                 </a:solidFill>
-                <a:latin typeface="PingFang SC"/>
-                <a:ea typeface="PingFang SC"/>
-                <a:cs typeface="PingFang SC"/>
+                <a:latin typeface="Microsoft YaHei"/>
+                <a:ea typeface="Microsoft YaHei"/>
+                <a:cs typeface="Microsoft YaHei"/>
               </a:defRPr>
             </a:pPr>
             <a:r>
@@ -8388,9 +8388,9 @@
                 <a:solidFill>
                   <a:srgbClr val="5F6368"/>
                 </a:solidFill>
-                <a:latin typeface="PingFang SC"/>
-                <a:ea typeface="PingFang SC"/>
-                <a:cs typeface="PingFang SC"/>
+                <a:latin typeface="Microsoft YaHei"/>
+                <a:ea typeface="Microsoft YaHei"/>
+                <a:cs typeface="Microsoft YaHei"/>
               </a:defRPr>
             </a:pPr>
             <a:r>
@@ -8468,9 +8468,9 @@
                 <a:solidFill>
                   <a:srgbClr val="050505"/>
                 </a:solidFill>
-                <a:latin typeface="PingFang SC"/>
-                <a:ea typeface="PingFang SC"/>
-                <a:cs typeface="PingFang SC"/>
+                <a:latin typeface="Microsoft YaHei"/>
+                <a:ea typeface="Microsoft YaHei"/>
+                <a:cs typeface="Microsoft YaHei"/>
               </a:defRPr>
             </a:pPr>
             <a:r>
@@ -8513,9 +8513,9 @@
                 <a:solidFill>
                   <a:srgbClr val="5F6368"/>
                 </a:solidFill>
-                <a:latin typeface="PingFang SC"/>
-                <a:ea typeface="PingFang SC"/>
-                <a:cs typeface="PingFang SC"/>
+                <a:latin typeface="Microsoft YaHei"/>
+                <a:ea typeface="Microsoft YaHei"/>
+                <a:cs typeface="Microsoft YaHei"/>
               </a:defRPr>
             </a:pPr>
             <a:r>
@@ -8593,9 +8593,9 @@
                 <a:solidFill>
                   <a:srgbClr val="13233A"/>
                 </a:solidFill>
-                <a:latin typeface="PingFang SC"/>
-                <a:ea typeface="PingFang SC"/>
-                <a:cs typeface="PingFang SC"/>
+                <a:latin typeface="Microsoft YaHei"/>
+                <a:ea typeface="Microsoft YaHei"/>
+                <a:cs typeface="Microsoft YaHei"/>
               </a:defRPr>
             </a:pPr>
             <a:r>
@@ -8735,9 +8735,9 @@
                 <a:solidFill>
                   <a:srgbClr val="FFFFFF"/>
                 </a:solidFill>
-                <a:latin typeface="PingFang SC"/>
-                <a:ea typeface="PingFang SC"/>
-                <a:cs typeface="PingFang SC"/>
+                <a:latin typeface="Microsoft YaHei"/>
+                <a:ea typeface="Microsoft YaHei"/>
+                <a:cs typeface="Microsoft YaHei"/>
               </a:defRPr>
             </a:pPr>
             <a:r>
@@ -8813,9 +8813,9 @@
                 <a:solidFill>
                   <a:srgbClr val="5F6368"/>
                 </a:solidFill>
-                <a:latin typeface="PingFang SC"/>
-                <a:ea typeface="PingFang SC"/>
-                <a:cs typeface="PingFang SC"/>
+                <a:latin typeface="Microsoft YaHei"/>
+                <a:ea typeface="Microsoft YaHei"/>
+                <a:cs typeface="Microsoft YaHei"/>
               </a:defRPr>
             </a:pPr>
             <a:r>
@@ -8858,9 +8858,9 @@
                 <a:solidFill>
                   <a:srgbClr val="5F6368"/>
                 </a:solidFill>
-                <a:latin typeface="PingFang SC"/>
-                <a:ea typeface="PingFang SC"/>
-                <a:cs typeface="PingFang SC"/>
+                <a:latin typeface="Microsoft YaHei"/>
+                <a:ea typeface="Microsoft YaHei"/>
+                <a:cs typeface="Microsoft YaHei"/>
               </a:defRPr>
             </a:pPr>
             <a:r>
@@ -8932,9 +8932,9 @@
                 <a:solidFill>
                   <a:srgbClr val="3D8DFF"/>
                 </a:solidFill>
-                <a:latin typeface="PingFang SC"/>
-                <a:ea typeface="PingFang SC"/>
-                <a:cs typeface="PingFang SC"/>
+                <a:latin typeface="Microsoft YaHei"/>
+                <a:ea typeface="Microsoft YaHei"/>
+                <a:cs typeface="Microsoft YaHei"/>
               </a:defRPr>
             </a:pPr>
             <a:r>
@@ -8977,9 +8977,9 @@
                 <a:solidFill>
                   <a:srgbClr val="050505"/>
                 </a:solidFill>
-                <a:latin typeface="PingFang SC"/>
-                <a:ea typeface="PingFang SC"/>
-                <a:cs typeface="PingFang SC"/>
+                <a:latin typeface="Microsoft YaHei"/>
+                <a:ea typeface="Microsoft YaHei"/>
+                <a:cs typeface="Microsoft YaHei"/>
               </a:defRPr>
             </a:pPr>
             <a:r>
@@ -9022,9 +9022,9 @@
                 <a:solidFill>
                   <a:srgbClr val="5F6368"/>
                 </a:solidFill>
-                <a:latin typeface="PingFang SC"/>
-                <a:ea typeface="PingFang SC"/>
-                <a:cs typeface="PingFang SC"/>
+                <a:latin typeface="Microsoft YaHei"/>
+                <a:ea typeface="Microsoft YaHei"/>
+                <a:cs typeface="Microsoft YaHei"/>
               </a:defRPr>
             </a:pPr>
             <a:r>
@@ -9102,9 +9102,9 @@
                 <a:solidFill>
                   <a:srgbClr val="5F6368"/>
                 </a:solidFill>
-                <a:latin typeface="PingFang SC"/>
-                <a:ea typeface="PingFang SC"/>
-                <a:cs typeface="PingFang SC"/>
+                <a:latin typeface="Microsoft YaHei"/>
+                <a:ea typeface="Microsoft YaHei"/>
+                <a:cs typeface="Microsoft YaHei"/>
               </a:defRPr>
             </a:pPr>
             <a:r>
@@ -9217,9 +9217,9 @@
                 <a:solidFill>
                   <a:srgbClr val="050505"/>
                 </a:solidFill>
-                <a:latin typeface="PingFang SC"/>
-                <a:ea typeface="PingFang SC"/>
-                <a:cs typeface="PingFang SC"/>
+                <a:latin typeface="Microsoft YaHei"/>
+                <a:ea typeface="Microsoft YaHei"/>
+                <a:cs typeface="Microsoft YaHei"/>
               </a:defRPr>
             </a:pPr>
             <a:r>
@@ -9262,9 +9262,9 @@
                 <a:solidFill>
                   <a:srgbClr val="5F6368"/>
                 </a:solidFill>
-                <a:latin typeface="PingFang SC"/>
-                <a:ea typeface="PingFang SC"/>
-                <a:cs typeface="PingFang SC"/>
+                <a:latin typeface="Microsoft YaHei"/>
+                <a:ea typeface="Microsoft YaHei"/>
+                <a:cs typeface="Microsoft YaHei"/>
               </a:defRPr>
             </a:pPr>
             <a:r>
@@ -9307,9 +9307,9 @@
                 <a:solidFill>
                   <a:srgbClr val="050505"/>
                 </a:solidFill>
-                <a:latin typeface="PingFang SC"/>
-                <a:ea typeface="PingFang SC"/>
-                <a:cs typeface="PingFang SC"/>
+                <a:latin typeface="Microsoft YaHei"/>
+                <a:ea typeface="Microsoft YaHei"/>
+                <a:cs typeface="Microsoft YaHei"/>
               </a:defRPr>
             </a:pPr>
             <a:r>
@@ -9352,9 +9352,9 @@
                 <a:solidFill>
                   <a:srgbClr val="5F6368"/>
                 </a:solidFill>
-                <a:latin typeface="PingFang SC"/>
-                <a:ea typeface="PingFang SC"/>
-                <a:cs typeface="PingFang SC"/>
+                <a:latin typeface="Microsoft YaHei"/>
+                <a:ea typeface="Microsoft YaHei"/>
+                <a:cs typeface="Microsoft YaHei"/>
               </a:defRPr>
             </a:pPr>
             <a:r>
@@ -9432,9 +9432,9 @@
                 <a:solidFill>
                   <a:srgbClr val="FFFFFF"/>
                 </a:solidFill>
-                <a:latin typeface="PingFang SC"/>
-                <a:ea typeface="PingFang SC"/>
-                <a:cs typeface="PingFang SC"/>
+                <a:latin typeface="Microsoft YaHei"/>
+                <a:ea typeface="Microsoft YaHei"/>
+                <a:cs typeface="Microsoft YaHei"/>
               </a:defRPr>
             </a:pPr>
             <a:r>
@@ -9477,9 +9477,9 @@
                 <a:solidFill>
                   <a:srgbClr val="FFFFFF"/>
                 </a:solidFill>
-                <a:latin typeface="PingFang SC"/>
-                <a:ea typeface="PingFang SC"/>
-                <a:cs typeface="PingFang SC"/>
+                <a:latin typeface="Microsoft YaHei"/>
+                <a:ea typeface="Microsoft YaHei"/>
+                <a:cs typeface="Microsoft YaHei"/>
               </a:defRPr>
             </a:pPr>
             <a:r>
@@ -9522,9 +9522,9 @@
                 <a:solidFill>
                   <a:srgbClr val="5F6368"/>
                 </a:solidFill>
-                <a:latin typeface="PingFang SC"/>
-                <a:ea typeface="PingFang SC"/>
-                <a:cs typeface="PingFang SC"/>
+                <a:latin typeface="Microsoft YaHei"/>
+                <a:ea typeface="Microsoft YaHei"/>
+                <a:cs typeface="Microsoft YaHei"/>
               </a:defRPr>
             </a:pPr>
             <a:r>
@@ -9707,9 +9707,9 @@
                 <a:solidFill>
                   <a:srgbClr val="050505"/>
                 </a:solidFill>
-                <a:latin typeface="PingFang SC"/>
-                <a:ea typeface="PingFang SC"/>
-                <a:cs typeface="PingFang SC"/>
+                <a:latin typeface="Microsoft YaHei"/>
+                <a:ea typeface="Microsoft YaHei"/>
+                <a:cs typeface="Microsoft YaHei"/>
               </a:defRPr>
             </a:pPr>
             <a:r>
@@ -9752,9 +9752,9 @@
                 <a:solidFill>
                   <a:srgbClr val="050505"/>
                 </a:solidFill>
-                <a:latin typeface="PingFang SC"/>
-                <a:ea typeface="PingFang SC"/>
-                <a:cs typeface="PingFang SC"/>
+                <a:latin typeface="Microsoft YaHei"/>
+                <a:ea typeface="Microsoft YaHei"/>
+                <a:cs typeface="Microsoft YaHei"/>
               </a:defRPr>
             </a:pPr>
             <a:r>
@@ -9797,9 +9797,9 @@
                 <a:solidFill>
                   <a:srgbClr val="050505"/>
                 </a:solidFill>
-                <a:latin typeface="PingFang SC"/>
-                <a:ea typeface="PingFang SC"/>
-                <a:cs typeface="PingFang SC"/>
+                <a:latin typeface="Microsoft YaHei"/>
+                <a:ea typeface="Microsoft YaHei"/>
+                <a:cs typeface="Microsoft YaHei"/>
               </a:defRPr>
             </a:pPr>
             <a:r>
@@ -9842,9 +9842,9 @@
                 <a:solidFill>
                   <a:srgbClr val="050505"/>
                 </a:solidFill>
-                <a:latin typeface="PingFang SC"/>
-                <a:ea typeface="PingFang SC"/>
-                <a:cs typeface="PingFang SC"/>
+                <a:latin typeface="Microsoft YaHei"/>
+                <a:ea typeface="Microsoft YaHei"/>
+                <a:cs typeface="Microsoft YaHei"/>
               </a:defRPr>
             </a:pPr>
             <a:r>
@@ -9947,9 +9947,9 @@
                 <a:solidFill>
                   <a:srgbClr val="5F6368"/>
                 </a:solidFill>
-                <a:latin typeface="PingFang SC"/>
-                <a:ea typeface="PingFang SC"/>
-                <a:cs typeface="PingFang SC"/>
+                <a:latin typeface="Microsoft YaHei"/>
+                <a:ea typeface="Microsoft YaHei"/>
+                <a:cs typeface="Microsoft YaHei"/>
               </a:defRPr>
             </a:pPr>
             <a:r>
@@ -9992,9 +9992,9 @@
                 <a:solidFill>
                   <a:srgbClr val="5F6368"/>
                 </a:solidFill>
-                <a:latin typeface="PingFang SC"/>
-                <a:ea typeface="PingFang SC"/>
-                <a:cs typeface="PingFang SC"/>
+                <a:latin typeface="Microsoft YaHei"/>
+                <a:ea typeface="Microsoft YaHei"/>
+                <a:cs typeface="Microsoft YaHei"/>
               </a:defRPr>
             </a:pPr>
             <a:r>
@@ -10115,9 +10115,9 @@
                 <a:solidFill>
                   <a:srgbClr val="3D8DFF"/>
                 </a:solidFill>
-                <a:latin typeface="PingFang SC"/>
-                <a:ea typeface="PingFang SC"/>
-                <a:cs typeface="PingFang SC"/>
+                <a:latin typeface="Microsoft YaHei"/>
+                <a:ea typeface="Microsoft YaHei"/>
+                <a:cs typeface="Microsoft YaHei"/>
               </a:defRPr>
             </a:pPr>
             <a:r>
@@ -10160,9 +10160,9 @@
                 <a:solidFill>
                   <a:srgbClr val="050505"/>
                 </a:solidFill>
-                <a:latin typeface="PingFang SC"/>
-                <a:ea typeface="PingFang SC"/>
-                <a:cs typeface="PingFang SC"/>
+                <a:latin typeface="Microsoft YaHei"/>
+                <a:ea typeface="Microsoft YaHei"/>
+                <a:cs typeface="Microsoft YaHei"/>
               </a:defRPr>
             </a:pPr>
             <a:r>
@@ -10242,9 +10242,9 @@
                 <a:solidFill>
                   <a:srgbClr val="3D8DFF"/>
                 </a:solidFill>
-                <a:latin typeface="PingFang SC"/>
-                <a:ea typeface="PingFang SC"/>
-                <a:cs typeface="PingFang SC"/>
+                <a:latin typeface="Microsoft YaHei"/>
+                <a:ea typeface="Microsoft YaHei"/>
+                <a:cs typeface="Microsoft YaHei"/>
               </a:defRPr>
             </a:pPr>
             <a:r>
@@ -10287,9 +10287,9 @@
                 <a:solidFill>
                   <a:srgbClr val="050505"/>
                 </a:solidFill>
-                <a:latin typeface="PingFang SC"/>
-                <a:ea typeface="PingFang SC"/>
-                <a:cs typeface="PingFang SC"/>
+                <a:latin typeface="Microsoft YaHei"/>
+                <a:ea typeface="Microsoft YaHei"/>
+                <a:cs typeface="Microsoft YaHei"/>
               </a:defRPr>
             </a:pPr>
             <a:r>
@@ -10366,9 +10366,9 @@
                 <a:solidFill>
                   <a:srgbClr val="13233A"/>
                 </a:solidFill>
-                <a:latin typeface="PingFang SC"/>
-                <a:ea typeface="PingFang SC"/>
-                <a:cs typeface="PingFang SC"/>
+                <a:latin typeface="Microsoft YaHei"/>
+                <a:ea typeface="Microsoft YaHei"/>
+                <a:cs typeface="Microsoft YaHei"/>
               </a:defRPr>
             </a:pPr>
             <a:r>
@@ -10448,9 +10448,9 @@
                 <a:solidFill>
                   <a:srgbClr val="FFFFFF"/>
                 </a:solidFill>
-                <a:latin typeface="PingFang SC"/>
-                <a:ea typeface="PingFang SC"/>
-                <a:cs typeface="PingFang SC"/>
+                <a:latin typeface="Microsoft YaHei"/>
+                <a:ea typeface="Microsoft YaHei"/>
+                <a:cs typeface="Microsoft YaHei"/>
               </a:defRPr>
             </a:pPr>
             <a:r>
@@ -10493,9 +10493,9 @@
                 <a:solidFill>
                   <a:srgbClr val="6DCBF4"/>
                 </a:solidFill>
-                <a:latin typeface="PingFang SC"/>
-                <a:ea typeface="PingFang SC"/>
-                <a:cs typeface="PingFang SC"/>
+                <a:latin typeface="Microsoft YaHei"/>
+                <a:ea typeface="Microsoft YaHei"/>
+                <a:cs typeface="Microsoft YaHei"/>
               </a:defRPr>
             </a:pPr>
             <a:r>
@@ -10538,9 +10538,9 @@
                 <a:solidFill>
                   <a:srgbClr val="5F6368"/>
                 </a:solidFill>
-                <a:latin typeface="PingFang SC"/>
-                <a:ea typeface="PingFang SC"/>
-                <a:cs typeface="PingFang SC"/>
+                <a:latin typeface="Microsoft YaHei"/>
+                <a:ea typeface="Microsoft YaHei"/>
+                <a:cs typeface="Microsoft YaHei"/>
               </a:defRPr>
             </a:pPr>
             <a:r>
@@ -10583,9 +10583,9 @@
                 <a:solidFill>
                   <a:srgbClr val="5F6368"/>
                 </a:solidFill>
-                <a:latin typeface="PingFang SC"/>
-                <a:ea typeface="PingFang SC"/>
-                <a:cs typeface="PingFang SC"/>
+                <a:latin typeface="Microsoft YaHei"/>
+                <a:ea typeface="Microsoft YaHei"/>
+                <a:cs typeface="Microsoft YaHei"/>
               </a:defRPr>
             </a:pPr>
             <a:r>

</xml_diff>